<commit_message>
Update short link to tinyurl.com/lika-nexus across README, decks, and demo script
</commit_message>
<xml_diff>
--- a/LIKA_Concept_Paper.pptx
+++ b/LIKA_Concept_Paper.pptx
@@ -2230,7 +2230,7 @@
                 <a:latin typeface="Tahoma"/>
                 <a:cs typeface="Tahoma"/>
               </a:rPr>
-              <a:t>https://tinyurl.com/2u452bd4</a:t>
+              <a:t>https://tinyurl.com/lika-nexus</a:t>
             </a:r>
           </a:p>
         </p:txBody>
@@ -11038,7 +11038,7 @@
                 <a:latin typeface="Tahoma"/>
                 <a:cs typeface="Tahoma"/>
               </a:rPr>
-              <a:t>เผยแพร่ออนไลน์แล้ว · tinyurl.com/2u452bd4</a:t>
+              <a:t>เผยแพร่ออนไลน์แล้ว · tinyurl.com/lika-nexus</a:t>
             </a:r>
           </a:p>
         </p:txBody>

</xml_diff>

<commit_message>
Remove score numbers from Concept Paper deck (per user intent): corner badges and summary column replaced with checkmarks
</commit_message>
<xml_diff>
--- a/LIKA_Concept_Paper.pptx
+++ b/LIKA_Concept_Paper.pptx
@@ -2270,7 +2270,7 @@
       </p:grpSpPr>
       <p:sp>
         <p:nvSpPr>
-          <p:cNvPr id="294" name="s"/>
+          <p:cNvPr id="282" name="s"/>
           <p:cNvSpPr/>
           <p:nvPr/>
         </p:nvSpPr>
@@ -2297,7 +2297,7 @@
       </p:sp>
       <p:sp>
         <p:nvSpPr>
-          <p:cNvPr id="295" name="s"/>
+          <p:cNvPr id="283" name="s"/>
           <p:cNvSpPr/>
           <p:nvPr/>
         </p:nvSpPr>
@@ -2324,7 +2324,7 @@
       </p:sp>
       <p:sp>
         <p:nvSpPr>
-          <p:cNvPr id="296" name="s"/>
+          <p:cNvPr id="284" name="s"/>
           <p:cNvSpPr/>
           <p:nvPr/>
         </p:nvSpPr>
@@ -2351,7 +2351,7 @@
       </p:sp>
       <p:sp>
         <p:nvSpPr>
-          <p:cNvPr id="297" name="s"/>
+          <p:cNvPr id="285" name="s"/>
           <p:cNvSpPr/>
           <p:nvPr/>
         </p:nvSpPr>
@@ -2378,7 +2378,7 @@
       </p:sp>
       <p:sp>
         <p:nvSpPr>
-          <p:cNvPr id="298" name="s"/>
+          <p:cNvPr id="286" name="s"/>
           <p:cNvSpPr/>
           <p:nvPr/>
         </p:nvSpPr>
@@ -2405,7 +2405,7 @@
       </p:sp>
       <p:sp>
         <p:nvSpPr>
-          <p:cNvPr id="299" name="s"/>
+          <p:cNvPr id="287" name="s"/>
           <p:cNvSpPr/>
           <p:nvPr/>
         </p:nvSpPr>
@@ -2432,7 +2432,7 @@
       </p:sp>
       <p:sp>
         <p:nvSpPr>
-          <p:cNvPr id="300" name="s"/>
+          <p:cNvPr id="288" name="s"/>
           <p:cNvSpPr/>
           <p:nvPr/>
         </p:nvSpPr>
@@ -2459,7 +2459,7 @@
       </p:sp>
       <p:sp>
         <p:nvSpPr>
-          <p:cNvPr id="301" name="s"/>
+          <p:cNvPr id="289" name="s"/>
           <p:cNvSpPr/>
           <p:nvPr/>
         </p:nvSpPr>
@@ -2486,7 +2486,7 @@
       </p:sp>
       <p:sp>
         <p:nvSpPr>
-          <p:cNvPr id="302" name="s"/>
+          <p:cNvPr id="290" name="s"/>
           <p:cNvSpPr/>
           <p:nvPr/>
         </p:nvSpPr>
@@ -2513,7 +2513,7 @@
       </p:sp>
       <p:sp>
         <p:nvSpPr>
-          <p:cNvPr id="303" name="s"/>
+          <p:cNvPr id="291" name="s"/>
           <p:cNvSpPr/>
           <p:nvPr/>
         </p:nvSpPr>
@@ -2540,7 +2540,7 @@
       </p:sp>
       <p:sp>
         <p:nvSpPr>
-          <p:cNvPr id="304" name="s"/>
+          <p:cNvPr id="292" name="s"/>
           <p:cNvSpPr/>
           <p:nvPr/>
         </p:nvSpPr>
@@ -2567,7 +2567,7 @@
       </p:sp>
       <p:sp>
         <p:nvSpPr>
-          <p:cNvPr id="305" name="s"/>
+          <p:cNvPr id="293" name="s"/>
           <p:cNvSpPr/>
           <p:nvPr/>
         </p:nvSpPr>
@@ -2594,7 +2594,7 @@
       </p:sp>
       <p:sp>
         <p:nvSpPr>
-          <p:cNvPr id="306" name="s"/>
+          <p:cNvPr id="294" name="s"/>
           <p:cNvSpPr/>
           <p:nvPr/>
         </p:nvSpPr>
@@ -2621,7 +2621,7 @@
       </p:sp>
       <p:sp>
         <p:nvSpPr>
-          <p:cNvPr id="307" name="s"/>
+          <p:cNvPr id="295" name="s"/>
           <p:cNvSpPr/>
           <p:nvPr/>
         </p:nvSpPr>
@@ -2648,7 +2648,7 @@
       </p:sp>
       <p:sp>
         <p:nvSpPr>
-          <p:cNvPr id="308" name="s"/>
+          <p:cNvPr id="296" name="s"/>
           <p:cNvSpPr/>
           <p:nvPr/>
         </p:nvSpPr>
@@ -2675,7 +2675,7 @@
       </p:sp>
       <p:sp>
         <p:nvSpPr>
-          <p:cNvPr id="309" name="s"/>
+          <p:cNvPr id="297" name="s"/>
           <p:cNvSpPr/>
           <p:nvPr/>
         </p:nvSpPr>
@@ -2702,7 +2702,7 @@
       </p:sp>
       <p:sp>
         <p:nvSpPr>
-          <p:cNvPr id="310" name="s"/>
+          <p:cNvPr id="298" name="s"/>
           <p:cNvSpPr/>
           <p:nvPr/>
         </p:nvSpPr>
@@ -2729,7 +2729,7 @@
       </p:sp>
       <p:sp>
         <p:nvSpPr>
-          <p:cNvPr id="311" name="s"/>
+          <p:cNvPr id="299" name="s"/>
           <p:cNvSpPr/>
           <p:nvPr/>
         </p:nvSpPr>
@@ -2756,7 +2756,7 @@
       </p:sp>
       <p:sp>
         <p:nvSpPr>
-          <p:cNvPr id="312" name="s"/>
+          <p:cNvPr id="300" name="s"/>
           <p:cNvSpPr/>
           <p:nvPr/>
         </p:nvSpPr>
@@ -2783,7 +2783,7 @@
       </p:sp>
       <p:sp>
         <p:nvSpPr>
-          <p:cNvPr id="313" name="s"/>
+          <p:cNvPr id="301" name="s"/>
           <p:cNvSpPr/>
           <p:nvPr/>
         </p:nvSpPr>
@@ -2810,7 +2810,7 @@
       </p:sp>
       <p:sp>
         <p:nvSpPr>
-          <p:cNvPr id="314" name="s"/>
+          <p:cNvPr id="302" name="s"/>
           <p:cNvSpPr/>
           <p:nvPr/>
         </p:nvSpPr>
@@ -2837,7 +2837,7 @@
       </p:sp>
       <p:sp>
         <p:nvSpPr>
-          <p:cNvPr id="315" name="s"/>
+          <p:cNvPr id="303" name="s"/>
           <p:cNvSpPr/>
           <p:nvPr/>
         </p:nvSpPr>
@@ -2864,7 +2864,7 @@
       </p:sp>
       <p:sp>
         <p:nvSpPr>
-          <p:cNvPr id="316" name="s"/>
+          <p:cNvPr id="304" name="s"/>
           <p:cNvSpPr/>
           <p:nvPr/>
         </p:nvSpPr>
@@ -2891,7 +2891,7 @@
       </p:sp>
       <p:sp>
         <p:nvSpPr>
-          <p:cNvPr id="317" name="s"/>
+          <p:cNvPr id="305" name="s"/>
           <p:cNvSpPr/>
           <p:nvPr/>
         </p:nvSpPr>
@@ -2918,7 +2918,7 @@
       </p:sp>
       <p:sp>
         <p:nvSpPr>
-          <p:cNvPr id="318" name="s"/>
+          <p:cNvPr id="306" name="s"/>
           <p:cNvSpPr/>
           <p:nvPr/>
         </p:nvSpPr>
@@ -2945,7 +2945,7 @@
       </p:sp>
       <p:sp>
         <p:nvSpPr>
-          <p:cNvPr id="319" name="s"/>
+          <p:cNvPr id="307" name="s"/>
           <p:cNvSpPr/>
           <p:nvPr/>
         </p:nvSpPr>
@@ -2972,7 +2972,7 @@
       </p:sp>
       <p:sp>
         <p:nvSpPr>
-          <p:cNvPr id="320" name="s"/>
+          <p:cNvPr id="308" name="s"/>
           <p:cNvSpPr/>
           <p:nvPr/>
         </p:nvSpPr>
@@ -2999,7 +2999,7 @@
       </p:sp>
       <p:sp>
         <p:nvSpPr>
-          <p:cNvPr id="321" name="s"/>
+          <p:cNvPr id="309" name="s"/>
           <p:cNvSpPr/>
           <p:nvPr/>
         </p:nvSpPr>
@@ -3026,7 +3026,7 @@
       </p:sp>
       <p:sp>
         <p:nvSpPr>
-          <p:cNvPr id="322" name="s"/>
+          <p:cNvPr id="310" name="s"/>
           <p:cNvSpPr/>
           <p:nvPr/>
         </p:nvSpPr>
@@ -3053,7 +3053,7 @@
       </p:sp>
       <p:sp>
         <p:nvSpPr>
-          <p:cNvPr id="323" name="s"/>
+          <p:cNvPr id="311" name="s"/>
           <p:cNvSpPr/>
           <p:nvPr/>
         </p:nvSpPr>
@@ -3080,7 +3080,7 @@
       </p:sp>
       <p:sp>
         <p:nvSpPr>
-          <p:cNvPr id="324" name="s"/>
+          <p:cNvPr id="312" name="s"/>
           <p:cNvSpPr/>
           <p:nvPr/>
         </p:nvSpPr>
@@ -3107,7 +3107,7 @@
       </p:sp>
       <p:sp>
         <p:nvSpPr>
-          <p:cNvPr id="325" name="s"/>
+          <p:cNvPr id="313" name="s"/>
           <p:cNvSpPr/>
           <p:nvPr/>
         </p:nvSpPr>
@@ -3134,7 +3134,7 @@
       </p:sp>
       <p:sp>
         <p:nvSpPr>
-          <p:cNvPr id="326" name="s"/>
+          <p:cNvPr id="314" name="s"/>
           <p:cNvSpPr/>
           <p:nvPr/>
         </p:nvSpPr>
@@ -3161,7 +3161,7 @@
       </p:sp>
       <p:sp>
         <p:nvSpPr>
-          <p:cNvPr id="327" name="s"/>
+          <p:cNvPr id="315" name="s"/>
           <p:cNvSpPr/>
           <p:nvPr/>
         </p:nvSpPr>
@@ -3188,7 +3188,7 @@
       </p:sp>
       <p:sp>
         <p:nvSpPr>
-          <p:cNvPr id="328" name="s"/>
+          <p:cNvPr id="316" name="s"/>
           <p:cNvSpPr/>
           <p:nvPr/>
         </p:nvSpPr>
@@ -3215,7 +3215,7 @@
       </p:sp>
       <p:sp>
         <p:nvSpPr>
-          <p:cNvPr id="329" name="s"/>
+          <p:cNvPr id="317" name="s"/>
           <p:cNvSpPr/>
           <p:nvPr/>
         </p:nvSpPr>
@@ -3242,7 +3242,7 @@
       </p:sp>
       <p:sp>
         <p:nvSpPr>
-          <p:cNvPr id="330" name="s"/>
+          <p:cNvPr id="318" name="s"/>
           <p:cNvSpPr/>
           <p:nvPr/>
         </p:nvSpPr>
@@ -3279,7 +3279,7 @@
       </p:sp>
       <p:sp>
         <p:nvSpPr>
-          <p:cNvPr id="331" name="t"/>
+          <p:cNvPr id="319" name="t"/>
           <p:cNvSpPr txBox="1"/>
           <p:nvPr/>
         </p:nvSpPr>
@@ -3308,14 +3308,14 @@
                 <a:latin typeface="Tahoma"/>
                 <a:cs typeface="Tahoma"/>
               </a:rPr>
-              <a:t>สรุปความสอดคล้องกับเกณฑ์พิจารณา</a:t>
-            </a:r>
-          </a:p>
-        </p:txBody>
-      </p:sp>
-      <p:sp>
-        <p:nvSpPr>
-          <p:cNvPr id="332" name="s"/>
+              <a:t>สรุปจุดเด่นของผลงาน</a:t>
+            </a:r>
+          </a:p>
+        </p:txBody>
+      </p:sp>
+      <p:sp>
+        <p:nvSpPr>
+          <p:cNvPr id="320" name="s"/>
           <p:cNvSpPr/>
           <p:nvPr/>
         </p:nvSpPr>
@@ -3346,7 +3346,7 @@
       </p:sp>
       <p:sp>
         <p:nvSpPr>
-          <p:cNvPr id="333" name="t"/>
+          <p:cNvPr id="321" name="t"/>
           <p:cNvSpPr txBox="1"/>
           <p:nvPr/>
         </p:nvSpPr>
@@ -3382,14 +3382,14 @@
       </p:sp>
       <p:sp>
         <p:nvSpPr>
-          <p:cNvPr id="334" name="t"/>
+          <p:cNvPr id="322" name="t"/>
           <p:cNvSpPr txBox="1"/>
           <p:nvPr/>
         </p:nvSpPr>
         <p:spPr>
           <a:xfrm>
             <a:off x="1700000" y="1910000"/>
-            <a:ext cx="7600000" cy="360000"/>
+            <a:ext cx="8600000" cy="360000"/>
           </a:xfrm>
           <a:prstGeom prst="rect">
             <a:avLst/>
@@ -3411,21 +3411,21 @@
                 <a:latin typeface="Tahoma"/>
                 <a:cs typeface="Tahoma"/>
               </a:rPr>
-              <a:t>ความสอดคล้องกับโจทย์ &amp; การใช้ Kiro</a:t>
-            </a:r>
-          </a:p>
-        </p:txBody>
-      </p:sp>
-      <p:sp>
-        <p:nvSpPr>
-          <p:cNvPr id="335" name="t"/>
+              <a:t>สอดคล้องกับโจทย์ &amp; พัฒนาด้วย Kiro</a:t>
+            </a:r>
+          </a:p>
+        </p:txBody>
+      </p:sp>
+      <p:sp>
+        <p:nvSpPr>
+          <p:cNvPr id="323" name="t"/>
           <p:cNvSpPr txBox="1"/>
           <p:nvPr/>
         </p:nvSpPr>
         <p:spPr>
           <a:xfrm>
             <a:off x="1700000" y="2250000"/>
-            <a:ext cx="7600000" cy="280000"/>
+            <a:ext cx="8600000" cy="280000"/>
           </a:xfrm>
           <a:prstGeom prst="rect">
             <a:avLst/>
@@ -3447,21 +3447,21 @@
                 <a:latin typeface="Tahoma"/>
                 <a:cs typeface="Tahoma"/>
               </a:rPr>
-              <a:t>พัฒนาด้วย Kiro ตลอดวงจร (Steering + Specs)</a:t>
-            </a:r>
-          </a:p>
-        </p:txBody>
-      </p:sp>
-      <p:sp>
-        <p:nvSpPr>
-          <p:cNvPr id="336" name="s"/>
-          <p:cNvSpPr/>
-          <p:nvPr/>
-        </p:nvSpPr>
-        <p:spPr>
-          <a:xfrm>
-            <a:off x="10350000" y="1960000"/>
-            <a:ext cx="950000" cy="420000"/>
+              <a:t>ใช้ Kiro ตลอดวงจร (Steering + Specs)</a:t>
+            </a:r>
+          </a:p>
+        </p:txBody>
+      </p:sp>
+      <p:sp>
+        <p:nvSpPr>
+          <p:cNvPr id="324" name="s"/>
+          <p:cNvSpPr/>
+          <p:nvPr/>
+        </p:nvSpPr>
+        <p:spPr>
+          <a:xfrm>
+            <a:off x="10350000" y="1990000"/>
+            <a:ext cx="950000" cy="370000"/>
           </a:xfrm>
           <a:prstGeom prst="roundRect">
             <a:avLst>
@@ -3483,14 +3483,14 @@
       </p:sp>
       <p:sp>
         <p:nvSpPr>
-          <p:cNvPr id="337" name="t"/>
-          <p:cNvSpPr txBox="1"/>
-          <p:nvPr/>
-        </p:nvSpPr>
-        <p:spPr>
-          <a:xfrm>
-            <a:off x="10350000" y="2010000"/>
-            <a:ext cx="950000" cy="330000"/>
+          <p:cNvPr id="325" name="t"/>
+          <p:cNvSpPr txBox="1"/>
+          <p:nvPr/>
+        </p:nvSpPr>
+        <p:spPr>
+          <a:xfrm>
+            <a:off x="10350000" y="2020000"/>
+            <a:ext cx="950000" cy="320000"/>
           </a:xfrm>
           <a:prstGeom prst="rect">
             <a:avLst/>
@@ -3512,14 +3512,14 @@
                 <a:latin typeface="Tahoma"/>
                 <a:cs typeface="Tahoma"/>
               </a:rPr>
-              <a:t>20</a:t>
-            </a:r>
-          </a:p>
-        </p:txBody>
-      </p:sp>
-      <p:sp>
-        <p:nvSpPr>
-          <p:cNvPr id="338" name="s"/>
+              <a:t>✓</a:t>
+            </a:r>
+          </a:p>
+        </p:txBody>
+      </p:sp>
+      <p:sp>
+        <p:nvSpPr>
+          <p:cNvPr id="326" name="s"/>
           <p:cNvSpPr/>
           <p:nvPr/>
         </p:nvSpPr>
@@ -3550,7 +3550,7 @@
       </p:sp>
       <p:sp>
         <p:nvSpPr>
-          <p:cNvPr id="339" name="t"/>
+          <p:cNvPr id="327" name="t"/>
           <p:cNvSpPr txBox="1"/>
           <p:nvPr/>
         </p:nvSpPr>
@@ -3586,14 +3586,14 @@
       </p:sp>
       <p:sp>
         <p:nvSpPr>
-          <p:cNvPr id="340" name="t"/>
+          <p:cNvPr id="328" name="t"/>
           <p:cNvSpPr txBox="1"/>
           <p:nvPr/>
         </p:nvSpPr>
         <p:spPr>
           <a:xfrm>
             <a:off x="1700000" y="2780000"/>
-            <a:ext cx="7600000" cy="360000"/>
+            <a:ext cx="8600000" cy="360000"/>
           </a:xfrm>
           <a:prstGeom prst="rect">
             <a:avLst/>
@@ -3622,14 +3622,14 @@
       </p:sp>
       <p:sp>
         <p:nvSpPr>
-          <p:cNvPr id="341" name="t"/>
+          <p:cNvPr id="329" name="t"/>
           <p:cNvSpPr txBox="1"/>
           <p:nvPr/>
         </p:nvSpPr>
         <p:spPr>
           <a:xfrm>
             <a:off x="1700000" y="3120000"/>
-            <a:ext cx="7600000" cy="280000"/>
+            <a:ext cx="8600000" cy="280000"/>
           </a:xfrm>
           <a:prstGeom prst="rect">
             <a:avLst/>
@@ -3658,14 +3658,14 @@
       </p:sp>
       <p:sp>
         <p:nvSpPr>
-          <p:cNvPr id="342" name="s"/>
-          <p:cNvSpPr/>
-          <p:nvPr/>
-        </p:nvSpPr>
-        <p:spPr>
-          <a:xfrm>
-            <a:off x="10350000" y="2830000"/>
-            <a:ext cx="950000" cy="420000"/>
+          <p:cNvPr id="330" name="s"/>
+          <p:cNvSpPr/>
+          <p:nvPr/>
+        </p:nvSpPr>
+        <p:spPr>
+          <a:xfrm>
+            <a:off x="10350000" y="2860000"/>
+            <a:ext cx="950000" cy="370000"/>
           </a:xfrm>
           <a:prstGeom prst="roundRect">
             <a:avLst>
@@ -3687,14 +3687,14 @@
       </p:sp>
       <p:sp>
         <p:nvSpPr>
-          <p:cNvPr id="343" name="t"/>
-          <p:cNvSpPr txBox="1"/>
-          <p:nvPr/>
-        </p:nvSpPr>
-        <p:spPr>
-          <a:xfrm>
-            <a:off x="10350000" y="2880000"/>
-            <a:ext cx="950000" cy="330000"/>
+          <p:cNvPr id="331" name="t"/>
+          <p:cNvSpPr txBox="1"/>
+          <p:nvPr/>
+        </p:nvSpPr>
+        <p:spPr>
+          <a:xfrm>
+            <a:off x="10350000" y="2890000"/>
+            <a:ext cx="950000" cy="320000"/>
           </a:xfrm>
           <a:prstGeom prst="rect">
             <a:avLst/>
@@ -3716,14 +3716,14 @@
                 <a:latin typeface="Tahoma"/>
                 <a:cs typeface="Tahoma"/>
               </a:rPr>
-              <a:t>20</a:t>
-            </a:r>
-          </a:p>
-        </p:txBody>
-      </p:sp>
-      <p:sp>
-        <p:nvSpPr>
-          <p:cNvPr id="344" name="s"/>
+              <a:t>✓</a:t>
+            </a:r>
+          </a:p>
+        </p:txBody>
+      </p:sp>
+      <p:sp>
+        <p:nvSpPr>
+          <p:cNvPr id="332" name="s"/>
           <p:cNvSpPr/>
           <p:nvPr/>
         </p:nvSpPr>
@@ -3754,7 +3754,7 @@
       </p:sp>
       <p:sp>
         <p:nvSpPr>
-          <p:cNvPr id="345" name="t"/>
+          <p:cNvPr id="333" name="t"/>
           <p:cNvSpPr txBox="1"/>
           <p:nvPr/>
         </p:nvSpPr>
@@ -3790,14 +3790,14 @@
       </p:sp>
       <p:sp>
         <p:nvSpPr>
-          <p:cNvPr id="346" name="t"/>
+          <p:cNvPr id="334" name="t"/>
           <p:cNvSpPr txBox="1"/>
           <p:nvPr/>
         </p:nvSpPr>
         <p:spPr>
           <a:xfrm>
             <a:off x="1700000" y="3650000"/>
-            <a:ext cx="7600000" cy="360000"/>
+            <a:ext cx="8600000" cy="360000"/>
           </a:xfrm>
           <a:prstGeom prst="rect">
             <a:avLst/>
@@ -3819,21 +3819,21 @@
                 <a:latin typeface="Tahoma"/>
                 <a:cs typeface="Tahoma"/>
               </a:rPr>
-              <a:t>ความเป็นไปได้ในการใช้จริง (Feasibility)</a:t>
-            </a:r>
-          </a:p>
-        </p:txBody>
-      </p:sp>
-      <p:sp>
-        <p:nvSpPr>
-          <p:cNvPr id="347" name="t"/>
+              <a:t>ความเป็นไปได้ในการใช้งานจริง</a:t>
+            </a:r>
+          </a:p>
+        </p:txBody>
+      </p:sp>
+      <p:sp>
+        <p:nvSpPr>
+          <p:cNvPr id="335" name="t"/>
           <p:cNvSpPr txBox="1"/>
           <p:nvPr/>
         </p:nvSpPr>
         <p:spPr>
           <a:xfrm>
             <a:off x="1700000" y="3990000"/>
-            <a:ext cx="7600000" cy="280000"/>
+            <a:ext cx="8600000" cy="280000"/>
           </a:xfrm>
           <a:prstGeom prst="rect">
             <a:avLst/>
@@ -3862,14 +3862,14 @@
       </p:sp>
       <p:sp>
         <p:nvSpPr>
-          <p:cNvPr id="348" name="s"/>
-          <p:cNvSpPr/>
-          <p:nvPr/>
-        </p:nvSpPr>
-        <p:spPr>
-          <a:xfrm>
-            <a:off x="10350000" y="3700000"/>
-            <a:ext cx="950000" cy="420000"/>
+          <p:cNvPr id="336" name="s"/>
+          <p:cNvSpPr/>
+          <p:nvPr/>
+        </p:nvSpPr>
+        <p:spPr>
+          <a:xfrm>
+            <a:off x="10350000" y="3730000"/>
+            <a:ext cx="950000" cy="370000"/>
           </a:xfrm>
           <a:prstGeom prst="roundRect">
             <a:avLst>
@@ -3891,14 +3891,14 @@
       </p:sp>
       <p:sp>
         <p:nvSpPr>
-          <p:cNvPr id="349" name="t"/>
-          <p:cNvSpPr txBox="1"/>
-          <p:nvPr/>
-        </p:nvSpPr>
-        <p:spPr>
-          <a:xfrm>
-            <a:off x="10350000" y="3750000"/>
-            <a:ext cx="950000" cy="330000"/>
+          <p:cNvPr id="337" name="t"/>
+          <p:cNvSpPr txBox="1"/>
+          <p:nvPr/>
+        </p:nvSpPr>
+        <p:spPr>
+          <a:xfrm>
+            <a:off x="10350000" y="3760000"/>
+            <a:ext cx="950000" cy="320000"/>
           </a:xfrm>
           <a:prstGeom prst="rect">
             <a:avLst/>
@@ -3920,14 +3920,14 @@
                 <a:latin typeface="Tahoma"/>
                 <a:cs typeface="Tahoma"/>
               </a:rPr>
-              <a:t>30</a:t>
-            </a:r>
-          </a:p>
-        </p:txBody>
-      </p:sp>
-      <p:sp>
-        <p:nvSpPr>
-          <p:cNvPr id="350" name="s"/>
+              <a:t>✓</a:t>
+            </a:r>
+          </a:p>
+        </p:txBody>
+      </p:sp>
+      <p:sp>
+        <p:nvSpPr>
+          <p:cNvPr id="338" name="s"/>
           <p:cNvSpPr/>
           <p:nvPr/>
         </p:nvSpPr>
@@ -3958,7 +3958,7 @@
       </p:sp>
       <p:sp>
         <p:nvSpPr>
-          <p:cNvPr id="351" name="t"/>
+          <p:cNvPr id="339" name="t"/>
           <p:cNvSpPr txBox="1"/>
           <p:nvPr/>
         </p:nvSpPr>
@@ -3994,14 +3994,14 @@
       </p:sp>
       <p:sp>
         <p:nvSpPr>
-          <p:cNvPr id="352" name="t"/>
+          <p:cNvPr id="340" name="t"/>
           <p:cNvSpPr txBox="1"/>
           <p:nvPr/>
         </p:nvSpPr>
         <p:spPr>
           <a:xfrm>
             <a:off x="1700000" y="4520000"/>
-            <a:ext cx="7600000" cy="360000"/>
+            <a:ext cx="8600000" cy="360000"/>
           </a:xfrm>
           <a:prstGeom prst="rect">
             <a:avLst/>
@@ -4030,14 +4030,14 @@
       </p:sp>
       <p:sp>
         <p:nvSpPr>
-          <p:cNvPr id="353" name="t"/>
+          <p:cNvPr id="341" name="t"/>
           <p:cNvSpPr txBox="1"/>
           <p:nvPr/>
         </p:nvSpPr>
         <p:spPr>
           <a:xfrm>
             <a:off x="1700000" y="4860000"/>
-            <a:ext cx="7600000" cy="280000"/>
+            <a:ext cx="8600000" cy="280000"/>
           </a:xfrm>
           <a:prstGeom prst="rect">
             <a:avLst/>
@@ -4066,14 +4066,14 @@
       </p:sp>
       <p:sp>
         <p:nvSpPr>
-          <p:cNvPr id="354" name="s"/>
-          <p:cNvSpPr/>
-          <p:nvPr/>
-        </p:nvSpPr>
-        <p:spPr>
-          <a:xfrm>
-            <a:off x="10350000" y="4570000"/>
-            <a:ext cx="950000" cy="420000"/>
+          <p:cNvPr id="342" name="s"/>
+          <p:cNvSpPr/>
+          <p:nvPr/>
+        </p:nvSpPr>
+        <p:spPr>
+          <a:xfrm>
+            <a:off x="10350000" y="4600000"/>
+            <a:ext cx="950000" cy="370000"/>
           </a:xfrm>
           <a:prstGeom prst="roundRect">
             <a:avLst>
@@ -4095,14 +4095,14 @@
       </p:sp>
       <p:sp>
         <p:nvSpPr>
-          <p:cNvPr id="355" name="t"/>
-          <p:cNvSpPr txBox="1"/>
-          <p:nvPr/>
-        </p:nvSpPr>
-        <p:spPr>
-          <a:xfrm>
-            <a:off x="10350000" y="4620000"/>
-            <a:ext cx="950000" cy="330000"/>
+          <p:cNvPr id="343" name="t"/>
+          <p:cNvSpPr txBox="1"/>
+          <p:nvPr/>
+        </p:nvSpPr>
+        <p:spPr>
+          <a:xfrm>
+            <a:off x="10350000" y="4630000"/>
+            <a:ext cx="950000" cy="320000"/>
           </a:xfrm>
           <a:prstGeom prst="rect">
             <a:avLst/>
@@ -4124,14 +4124,14 @@
                 <a:latin typeface="Tahoma"/>
                 <a:cs typeface="Tahoma"/>
               </a:rPr>
-              <a:t>20</a:t>
-            </a:r>
-          </a:p>
-        </p:txBody>
-      </p:sp>
-      <p:sp>
-        <p:nvSpPr>
-          <p:cNvPr id="356" name="s"/>
+              <a:t>✓</a:t>
+            </a:r>
+          </a:p>
+        </p:txBody>
+      </p:sp>
+      <p:sp>
+        <p:nvSpPr>
+          <p:cNvPr id="344" name="s"/>
           <p:cNvSpPr/>
           <p:nvPr/>
         </p:nvSpPr>
@@ -4162,7 +4162,7 @@
       </p:sp>
       <p:sp>
         <p:nvSpPr>
-          <p:cNvPr id="357" name="t"/>
+          <p:cNvPr id="345" name="t"/>
           <p:cNvSpPr txBox="1"/>
           <p:nvPr/>
         </p:nvSpPr>
@@ -4198,14 +4198,14 @@
       </p:sp>
       <p:sp>
         <p:nvSpPr>
-          <p:cNvPr id="358" name="t"/>
+          <p:cNvPr id="346" name="t"/>
           <p:cNvSpPr txBox="1"/>
           <p:nvPr/>
         </p:nvSpPr>
         <p:spPr>
           <a:xfrm>
             <a:off x="1700000" y="5390000"/>
-            <a:ext cx="7600000" cy="360000"/>
+            <a:ext cx="8600000" cy="360000"/>
           </a:xfrm>
           <a:prstGeom prst="rect">
             <a:avLst/>
@@ -4234,14 +4234,14 @@
       </p:sp>
       <p:sp>
         <p:nvSpPr>
-          <p:cNvPr id="359" name="t"/>
+          <p:cNvPr id="347" name="t"/>
           <p:cNvSpPr txBox="1"/>
           <p:nvPr/>
         </p:nvSpPr>
         <p:spPr>
           <a:xfrm>
             <a:off x="1700000" y="5730000"/>
-            <a:ext cx="7600000" cy="280000"/>
+            <a:ext cx="8600000" cy="280000"/>
           </a:xfrm>
           <a:prstGeom prst="rect">
             <a:avLst/>
@@ -4270,14 +4270,14 @@
       </p:sp>
       <p:sp>
         <p:nvSpPr>
-          <p:cNvPr id="360" name="s"/>
-          <p:cNvSpPr/>
-          <p:nvPr/>
-        </p:nvSpPr>
-        <p:spPr>
-          <a:xfrm>
-            <a:off x="10350000" y="5440000"/>
-            <a:ext cx="950000" cy="420000"/>
+          <p:cNvPr id="348" name="s"/>
+          <p:cNvSpPr/>
+          <p:nvPr/>
+        </p:nvSpPr>
+        <p:spPr>
+          <a:xfrm>
+            <a:off x="10350000" y="5470000"/>
+            <a:ext cx="950000" cy="370000"/>
           </a:xfrm>
           <a:prstGeom prst="roundRect">
             <a:avLst>
@@ -4299,14 +4299,14 @@
       </p:sp>
       <p:sp>
         <p:nvSpPr>
-          <p:cNvPr id="361" name="t"/>
-          <p:cNvSpPr txBox="1"/>
-          <p:nvPr/>
-        </p:nvSpPr>
-        <p:spPr>
-          <a:xfrm>
-            <a:off x="10350000" y="5490000"/>
-            <a:ext cx="950000" cy="330000"/>
+          <p:cNvPr id="349" name="t"/>
+          <p:cNvSpPr txBox="1"/>
+          <p:nvPr/>
+        </p:nvSpPr>
+        <p:spPr>
+          <a:xfrm>
+            <a:off x="10350000" y="5500000"/>
+            <a:ext cx="950000" cy="320000"/>
           </a:xfrm>
           <a:prstGeom prst="rect">
             <a:avLst/>
@@ -4328,7 +4328,7 @@
                 <a:latin typeface="Tahoma"/>
                 <a:cs typeface="Tahoma"/>
               </a:rPr>
-              <a:t>10</a:t>
+              <a:t>✓</a:t>
             </a:r>
           </a:p>
         </p:txBody>
@@ -7824,107 +7824,6 @@
         </p:nvSpPr>
         <p:spPr>
           <a:xfrm>
-            <a:off x="9850000" y="470000"/>
-            <a:ext cx="1850000" cy="560000"/>
-          </a:xfrm>
-          <a:prstGeom prst="roundRect">
-            <a:avLst>
-              <a:gd name="adj" fmla="val 16000"/>
-            </a:avLst>
-          </a:prstGeom>
-          <a:noFill/>
-          <a:ln w="12700">
-            <a:solidFill>
-              <a:srgbClr val="f5c542"/>
-            </a:solidFill>
-          </a:ln>
-        </p:spPr>
-        <p:txBody>
-          <a:bodyPr/>
-          <a:lstStyle/>
-          <a:p/>
-        </p:txBody>
-      </p:sp>
-      <p:sp>
-        <p:nvSpPr>
-          <p:cNvPr id="178" name="t"/>
-          <p:cNvSpPr txBox="1"/>
-          <p:nvPr/>
-        </p:nvSpPr>
-        <p:spPr>
-          <a:xfrm>
-            <a:off x="9850000" y="520000"/>
-            <a:ext cx="1850000" cy="250000"/>
-          </a:xfrm>
-          <a:prstGeom prst="rect">
-            <a:avLst/>
-          </a:prstGeom>
-          <a:noFill/>
-        </p:spPr>
-        <p:txBody>
-          <a:bodyPr wrap="square" anchor="t">
-            <a:normAutofit/>
-          </a:bodyPr>
-          <a:lstStyle/>
-          <a:p>
-            <a:pPr algn="ctr"/>
-            <a:r>
-              <a:rPr lang="th-TH" sz="800" b="1" i="0" dirty="0">
-                <a:solidFill>
-                  <a:srgbClr val="22d3ee"/>
-                </a:solidFill>
-                <a:latin typeface="Tahoma"/>
-                <a:cs typeface="Tahoma"/>
-              </a:rPr>
-              <a:t>เกณฑ์ที่เกี่ยวข้อง</a:t>
-            </a:r>
-          </a:p>
-        </p:txBody>
-      </p:sp>
-      <p:sp>
-        <p:nvSpPr>
-          <p:cNvPr id="179" name="t"/>
-          <p:cNvSpPr txBox="1"/>
-          <p:nvPr/>
-        </p:nvSpPr>
-        <p:spPr>
-          <a:xfrm>
-            <a:off x="9850000" y="740000"/>
-            <a:ext cx="1850000" cy="260000"/>
-          </a:xfrm>
-          <a:prstGeom prst="rect">
-            <a:avLst/>
-          </a:prstGeom>
-          <a:noFill/>
-        </p:spPr>
-        <p:txBody>
-          <a:bodyPr wrap="square" anchor="t">
-            <a:normAutofit/>
-          </a:bodyPr>
-          <a:lstStyle/>
-          <a:p>
-            <a:pPr algn="ctr"/>
-            <a:r>
-              <a:rPr lang="th-TH" sz="1200" b="1" i="0" dirty="0">
-                <a:solidFill>
-                  <a:srgbClr val="f5c542"/>
-                </a:solidFill>
-                <a:latin typeface="Tahoma"/>
-                <a:cs typeface="Tahoma"/>
-              </a:rPr>
-              <a:t>20 คะแนน</a:t>
-            </a:r>
-          </a:p>
-        </p:txBody>
-      </p:sp>
-      <p:sp>
-        <p:nvSpPr>
-          <p:cNvPr id="180" name="s"/>
-          <p:cNvSpPr/>
-          <p:nvPr/>
-        </p:nvSpPr>
-        <p:spPr>
-          <a:xfrm>
             <a:off x="760000" y="1950000"/>
             <a:ext cx="5250000" cy="3750000"/>
           </a:xfrm>
@@ -7957,7 +7856,7 @@
       </p:sp>
       <p:sp>
         <p:nvSpPr>
-          <p:cNvPr id="181" name="s"/>
+          <p:cNvPr id="178" name="s"/>
           <p:cNvSpPr/>
           <p:nvPr/>
         </p:nvSpPr>
@@ -7993,7 +7892,7 @@
       </p:sp>
       <p:sp>
         <p:nvSpPr>
-          <p:cNvPr id="182" name="t"/>
+          <p:cNvPr id="179" name="t"/>
           <p:cNvSpPr txBox="1"/>
           <p:nvPr/>
         </p:nvSpPr>
@@ -8029,7 +7928,7 @@
       </p:sp>
       <p:sp>
         <p:nvSpPr>
-          <p:cNvPr id="183" name="t"/>
+          <p:cNvPr id="180" name="t"/>
           <p:cNvSpPr txBox="1"/>
           <p:nvPr/>
         </p:nvSpPr>
@@ -8065,7 +7964,7 @@
       </p:sp>
       <p:sp>
         <p:nvSpPr>
-          <p:cNvPr id="184" name="t"/>
+          <p:cNvPr id="181" name="t"/>
           <p:cNvSpPr txBox="1"/>
           <p:nvPr/>
         </p:nvSpPr>
@@ -8111,7 +8010,7 @@
       </p:sp>
       <p:sp>
         <p:nvSpPr>
-          <p:cNvPr id="185" name="t"/>
+          <p:cNvPr id="182" name="t"/>
           <p:cNvSpPr txBox="1"/>
           <p:nvPr/>
         </p:nvSpPr>
@@ -8157,7 +8056,7 @@
       </p:sp>
       <p:sp>
         <p:nvSpPr>
-          <p:cNvPr id="186" name="t"/>
+          <p:cNvPr id="183" name="t"/>
           <p:cNvSpPr txBox="1"/>
           <p:nvPr/>
         </p:nvSpPr>
@@ -8203,7 +8102,7 @@
       </p:sp>
       <p:sp>
         <p:nvSpPr>
-          <p:cNvPr id="187" name="t"/>
+          <p:cNvPr id="184" name="t"/>
           <p:cNvSpPr txBox="1"/>
           <p:nvPr/>
         </p:nvSpPr>
@@ -8249,7 +8148,7 @@
       </p:sp>
       <p:sp>
         <p:nvSpPr>
-          <p:cNvPr id="188" name="s"/>
+          <p:cNvPr id="185" name="s"/>
           <p:cNvSpPr/>
           <p:nvPr/>
         </p:nvSpPr>
@@ -8287,7 +8186,7 @@
       </p:sp>
       <p:sp>
         <p:nvSpPr>
-          <p:cNvPr id="189" name="t"/>
+          <p:cNvPr id="186" name="t"/>
           <p:cNvSpPr txBox="1"/>
           <p:nvPr/>
         </p:nvSpPr>
@@ -8323,7 +8222,7 @@
       </p:sp>
       <p:sp>
         <p:nvSpPr>
-          <p:cNvPr id="190" name="t"/>
+          <p:cNvPr id="187" name="t"/>
           <p:cNvSpPr txBox="1"/>
           <p:nvPr/>
         </p:nvSpPr>
@@ -8369,7 +8268,7 @@
       </p:sp>
       <p:sp>
         <p:nvSpPr>
-          <p:cNvPr id="191" name="t"/>
+          <p:cNvPr id="188" name="t"/>
           <p:cNvSpPr txBox="1"/>
           <p:nvPr/>
         </p:nvSpPr>
@@ -8415,7 +8314,7 @@
       </p:sp>
       <p:sp>
         <p:nvSpPr>
-          <p:cNvPr id="192" name="t"/>
+          <p:cNvPr id="189" name="t"/>
           <p:cNvSpPr txBox="1"/>
           <p:nvPr/>
         </p:nvSpPr>
@@ -8461,7 +8360,7 @@
       </p:sp>
       <p:sp>
         <p:nvSpPr>
-          <p:cNvPr id="193" name="t"/>
+          <p:cNvPr id="190" name="t"/>
           <p:cNvSpPr txBox="1"/>
           <p:nvPr/>
         </p:nvSpPr>
@@ -8540,7 +8439,7 @@
       </p:grpSpPr>
       <p:sp>
         <p:nvSpPr>
-          <p:cNvPr id="194" name="s"/>
+          <p:cNvPr id="191" name="s"/>
           <p:cNvSpPr/>
           <p:nvPr/>
         </p:nvSpPr>
@@ -8569,7 +8468,7 @@
       </p:sp>
       <p:sp>
         <p:nvSpPr>
-          <p:cNvPr id="195" name="t"/>
+          <p:cNvPr id="192" name="t"/>
           <p:cNvSpPr txBox="1"/>
           <p:nvPr/>
         </p:nvSpPr>
@@ -8605,7 +8504,7 @@
       </p:sp>
       <p:sp>
         <p:nvSpPr>
-          <p:cNvPr id="196" name="t"/>
+          <p:cNvPr id="193" name="t"/>
           <p:cNvSpPr txBox="1"/>
           <p:nvPr/>
         </p:nvSpPr>
@@ -8641,7 +8540,7 @@
       </p:sp>
       <p:sp>
         <p:nvSpPr>
-          <p:cNvPr id="197" name="t"/>
+          <p:cNvPr id="194" name="t"/>
           <p:cNvSpPr txBox="1"/>
           <p:nvPr/>
         </p:nvSpPr>
@@ -8677,108 +8576,7 @@
       </p:sp>
       <p:sp>
         <p:nvSpPr>
-          <p:cNvPr id="198" name="s"/>
-          <p:cNvSpPr/>
-          <p:nvPr/>
-        </p:nvSpPr>
-        <p:spPr>
-          <a:xfrm>
-            <a:off x="9850000" y="470000"/>
-            <a:ext cx="1850000" cy="560000"/>
-          </a:xfrm>
-          <a:prstGeom prst="roundRect">
-            <a:avLst>
-              <a:gd name="adj" fmla="val 16000"/>
-            </a:avLst>
-          </a:prstGeom>
-          <a:noFill/>
-          <a:ln w="12700">
-            <a:solidFill>
-              <a:srgbClr val="f5c542"/>
-            </a:solidFill>
-          </a:ln>
-        </p:spPr>
-        <p:txBody>
-          <a:bodyPr/>
-          <a:lstStyle/>
-          <a:p/>
-        </p:txBody>
-      </p:sp>
-      <p:sp>
-        <p:nvSpPr>
-          <p:cNvPr id="199" name="t"/>
-          <p:cNvSpPr txBox="1"/>
-          <p:nvPr/>
-        </p:nvSpPr>
-        <p:spPr>
-          <a:xfrm>
-            <a:off x="9850000" y="520000"/>
-            <a:ext cx="1850000" cy="250000"/>
-          </a:xfrm>
-          <a:prstGeom prst="rect">
-            <a:avLst/>
-          </a:prstGeom>
-          <a:noFill/>
-        </p:spPr>
-        <p:txBody>
-          <a:bodyPr wrap="square" anchor="t">
-            <a:normAutofit/>
-          </a:bodyPr>
-          <a:lstStyle/>
-          <a:p>
-            <a:pPr algn="ctr"/>
-            <a:r>
-              <a:rPr lang="th-TH" sz="800" b="1" i="0" dirty="0">
-                <a:solidFill>
-                  <a:srgbClr val="22d3ee"/>
-                </a:solidFill>
-                <a:latin typeface="Tahoma"/>
-                <a:cs typeface="Tahoma"/>
-              </a:rPr>
-              <a:t>เกณฑ์ที่เกี่ยวข้อง</a:t>
-            </a:r>
-          </a:p>
-        </p:txBody>
-      </p:sp>
-      <p:sp>
-        <p:nvSpPr>
-          <p:cNvPr id="200" name="t"/>
-          <p:cNvSpPr txBox="1"/>
-          <p:nvPr/>
-        </p:nvSpPr>
-        <p:spPr>
-          <a:xfrm>
-            <a:off x="9850000" y="740000"/>
-            <a:ext cx="1850000" cy="260000"/>
-          </a:xfrm>
-          <a:prstGeom prst="rect">
-            <a:avLst/>
-          </a:prstGeom>
-          <a:noFill/>
-        </p:spPr>
-        <p:txBody>
-          <a:bodyPr wrap="square" anchor="t">
-            <a:normAutofit/>
-          </a:bodyPr>
-          <a:lstStyle/>
-          <a:p>
-            <a:pPr algn="ctr"/>
-            <a:r>
-              <a:rPr lang="th-TH" sz="1200" b="1" i="0" dirty="0">
-                <a:solidFill>
-                  <a:srgbClr val="f5c542"/>
-                </a:solidFill>
-                <a:latin typeface="Tahoma"/>
-                <a:cs typeface="Tahoma"/>
-              </a:rPr>
-              <a:t>20 คะแนน</a:t>
-            </a:r>
-          </a:p>
-        </p:txBody>
-      </p:sp>
-      <p:sp>
-        <p:nvSpPr>
-          <p:cNvPr id="201" name="s"/>
+          <p:cNvPr id="195" name="s"/>
           <p:cNvSpPr/>
           <p:nvPr/>
         </p:nvSpPr>
@@ -8816,7 +8614,7 @@
       </p:sp>
       <p:sp>
         <p:nvSpPr>
-          <p:cNvPr id="202" name="s"/>
+          <p:cNvPr id="196" name="s"/>
           <p:cNvSpPr/>
           <p:nvPr/>
         </p:nvSpPr>
@@ -8852,7 +8650,7 @@
       </p:sp>
       <p:sp>
         <p:nvSpPr>
-          <p:cNvPr id="203" name="t"/>
+          <p:cNvPr id="197" name="t"/>
           <p:cNvSpPr txBox="1"/>
           <p:nvPr/>
         </p:nvSpPr>
@@ -8888,7 +8686,7 @@
       </p:sp>
       <p:sp>
         <p:nvSpPr>
-          <p:cNvPr id="204" name="t"/>
+          <p:cNvPr id="198" name="t"/>
           <p:cNvSpPr txBox="1"/>
           <p:nvPr/>
         </p:nvSpPr>
@@ -8924,7 +8722,7 @@
       </p:sp>
       <p:sp>
         <p:nvSpPr>
-          <p:cNvPr id="205" name="t"/>
+          <p:cNvPr id="199" name="t"/>
           <p:cNvSpPr txBox="1"/>
           <p:nvPr/>
         </p:nvSpPr>
@@ -8960,7 +8758,7 @@
       </p:sp>
       <p:sp>
         <p:nvSpPr>
-          <p:cNvPr id="206" name="t"/>
+          <p:cNvPr id="200" name="t"/>
           <p:cNvSpPr txBox="1"/>
           <p:nvPr/>
         </p:nvSpPr>
@@ -8996,7 +8794,7 @@
       </p:sp>
       <p:sp>
         <p:nvSpPr>
-          <p:cNvPr id="207" name="t"/>
+          <p:cNvPr id="201" name="t"/>
           <p:cNvSpPr txBox="1"/>
           <p:nvPr/>
         </p:nvSpPr>
@@ -9032,7 +8830,7 @@
       </p:sp>
       <p:sp>
         <p:nvSpPr>
-          <p:cNvPr id="208" name="s"/>
+          <p:cNvPr id="202" name="s"/>
           <p:cNvSpPr/>
           <p:nvPr/>
         </p:nvSpPr>
@@ -9070,7 +8868,7 @@
       </p:sp>
       <p:sp>
         <p:nvSpPr>
-          <p:cNvPr id="209" name="s"/>
+          <p:cNvPr id="203" name="s"/>
           <p:cNvSpPr/>
           <p:nvPr/>
         </p:nvSpPr>
@@ -9106,7 +8904,7 @@
       </p:sp>
       <p:sp>
         <p:nvSpPr>
-          <p:cNvPr id="210" name="t"/>
+          <p:cNvPr id="204" name="t"/>
           <p:cNvSpPr txBox="1"/>
           <p:nvPr/>
         </p:nvSpPr>
@@ -9142,7 +8940,7 @@
       </p:sp>
       <p:sp>
         <p:nvSpPr>
-          <p:cNvPr id="211" name="t"/>
+          <p:cNvPr id="205" name="t"/>
           <p:cNvSpPr txBox="1"/>
           <p:nvPr/>
         </p:nvSpPr>
@@ -9178,7 +8976,7 @@
       </p:sp>
       <p:sp>
         <p:nvSpPr>
-          <p:cNvPr id="212" name="t"/>
+          <p:cNvPr id="206" name="t"/>
           <p:cNvSpPr txBox="1"/>
           <p:nvPr/>
         </p:nvSpPr>
@@ -9214,7 +9012,7 @@
       </p:sp>
       <p:sp>
         <p:nvSpPr>
-          <p:cNvPr id="213" name="t"/>
+          <p:cNvPr id="207" name="t"/>
           <p:cNvSpPr txBox="1"/>
           <p:nvPr/>
         </p:nvSpPr>
@@ -9250,7 +9048,7 @@
       </p:sp>
       <p:sp>
         <p:nvSpPr>
-          <p:cNvPr id="214" name="t"/>
+          <p:cNvPr id="208" name="t"/>
           <p:cNvSpPr txBox="1"/>
           <p:nvPr/>
         </p:nvSpPr>
@@ -9286,7 +9084,7 @@
       </p:sp>
       <p:sp>
         <p:nvSpPr>
-          <p:cNvPr id="215" name="s"/>
+          <p:cNvPr id="209" name="s"/>
           <p:cNvSpPr/>
           <p:nvPr/>
         </p:nvSpPr>
@@ -9324,7 +9122,7 @@
       </p:sp>
       <p:sp>
         <p:nvSpPr>
-          <p:cNvPr id="216" name="s"/>
+          <p:cNvPr id="210" name="s"/>
           <p:cNvSpPr/>
           <p:nvPr/>
         </p:nvSpPr>
@@ -9360,7 +9158,7 @@
       </p:sp>
       <p:sp>
         <p:nvSpPr>
-          <p:cNvPr id="217" name="t"/>
+          <p:cNvPr id="211" name="t"/>
           <p:cNvSpPr txBox="1"/>
           <p:nvPr/>
         </p:nvSpPr>
@@ -9396,7 +9194,7 @@
       </p:sp>
       <p:sp>
         <p:nvSpPr>
-          <p:cNvPr id="218" name="t"/>
+          <p:cNvPr id="212" name="t"/>
           <p:cNvSpPr txBox="1"/>
           <p:nvPr/>
         </p:nvSpPr>
@@ -9432,7 +9230,7 @@
       </p:sp>
       <p:sp>
         <p:nvSpPr>
-          <p:cNvPr id="219" name="t"/>
+          <p:cNvPr id="213" name="t"/>
           <p:cNvSpPr txBox="1"/>
           <p:nvPr/>
         </p:nvSpPr>
@@ -9468,7 +9266,7 @@
       </p:sp>
       <p:sp>
         <p:nvSpPr>
-          <p:cNvPr id="220" name="t"/>
+          <p:cNvPr id="214" name="t"/>
           <p:cNvSpPr txBox="1"/>
           <p:nvPr/>
         </p:nvSpPr>
@@ -9504,7 +9302,7 @@
       </p:sp>
       <p:sp>
         <p:nvSpPr>
-          <p:cNvPr id="221" name="t"/>
+          <p:cNvPr id="215" name="t"/>
           <p:cNvSpPr txBox="1"/>
           <p:nvPr/>
         </p:nvSpPr>
@@ -9540,7 +9338,7 @@
       </p:sp>
       <p:sp>
         <p:nvSpPr>
-          <p:cNvPr id="222" name="s"/>
+          <p:cNvPr id="216" name="s"/>
           <p:cNvSpPr/>
           <p:nvPr/>
         </p:nvSpPr>
@@ -9578,7 +9376,7 @@
       </p:sp>
       <p:sp>
         <p:nvSpPr>
-          <p:cNvPr id="223" name="s"/>
+          <p:cNvPr id="217" name="s"/>
           <p:cNvSpPr/>
           <p:nvPr/>
         </p:nvSpPr>
@@ -9614,7 +9412,7 @@
       </p:sp>
       <p:sp>
         <p:nvSpPr>
-          <p:cNvPr id="224" name="t"/>
+          <p:cNvPr id="218" name="t"/>
           <p:cNvSpPr txBox="1"/>
           <p:nvPr/>
         </p:nvSpPr>
@@ -9650,7 +9448,7 @@
       </p:sp>
       <p:sp>
         <p:nvSpPr>
-          <p:cNvPr id="225" name="t"/>
+          <p:cNvPr id="219" name="t"/>
           <p:cNvSpPr txBox="1"/>
           <p:nvPr/>
         </p:nvSpPr>
@@ -9686,7 +9484,7 @@
       </p:sp>
       <p:sp>
         <p:nvSpPr>
-          <p:cNvPr id="226" name="t"/>
+          <p:cNvPr id="220" name="t"/>
           <p:cNvSpPr txBox="1"/>
           <p:nvPr/>
         </p:nvSpPr>
@@ -9722,7 +9520,7 @@
       </p:sp>
       <p:sp>
         <p:nvSpPr>
-          <p:cNvPr id="227" name="t"/>
+          <p:cNvPr id="221" name="t"/>
           <p:cNvSpPr txBox="1"/>
           <p:nvPr/>
         </p:nvSpPr>
@@ -9758,7 +9556,7 @@
       </p:sp>
       <p:sp>
         <p:nvSpPr>
-          <p:cNvPr id="228" name="s"/>
+          <p:cNvPr id="222" name="s"/>
           <p:cNvSpPr/>
           <p:nvPr/>
         </p:nvSpPr>
@@ -9787,7 +9585,7 @@
       </p:sp>
       <p:sp>
         <p:nvSpPr>
-          <p:cNvPr id="229" name="t"/>
+          <p:cNvPr id="223" name="t"/>
           <p:cNvSpPr txBox="1"/>
           <p:nvPr/>
         </p:nvSpPr>
@@ -9866,7 +9664,7 @@
       </p:grpSpPr>
       <p:sp>
         <p:nvSpPr>
-          <p:cNvPr id="230" name="s"/>
+          <p:cNvPr id="224" name="s"/>
           <p:cNvSpPr/>
           <p:nvPr/>
         </p:nvSpPr>
@@ -9895,7 +9693,7 @@
       </p:sp>
       <p:sp>
         <p:nvSpPr>
-          <p:cNvPr id="231" name="t"/>
+          <p:cNvPr id="225" name="t"/>
           <p:cNvSpPr txBox="1"/>
           <p:nvPr/>
         </p:nvSpPr>
@@ -9931,7 +9729,7 @@
       </p:sp>
       <p:sp>
         <p:nvSpPr>
-          <p:cNvPr id="232" name="t"/>
+          <p:cNvPr id="226" name="t"/>
           <p:cNvSpPr txBox="1"/>
           <p:nvPr/>
         </p:nvSpPr>
@@ -9967,7 +9765,7 @@
       </p:sp>
       <p:sp>
         <p:nvSpPr>
-          <p:cNvPr id="233" name="t"/>
+          <p:cNvPr id="227" name="t"/>
           <p:cNvSpPr txBox="1"/>
           <p:nvPr/>
         </p:nvSpPr>
@@ -10003,108 +9801,7 @@
       </p:sp>
       <p:sp>
         <p:nvSpPr>
-          <p:cNvPr id="234" name="s"/>
-          <p:cNvSpPr/>
-          <p:nvPr/>
-        </p:nvSpPr>
-        <p:spPr>
-          <a:xfrm>
-            <a:off x="9850000" y="470000"/>
-            <a:ext cx="1850000" cy="560000"/>
-          </a:xfrm>
-          <a:prstGeom prst="roundRect">
-            <a:avLst>
-              <a:gd name="adj" fmla="val 16000"/>
-            </a:avLst>
-          </a:prstGeom>
-          <a:noFill/>
-          <a:ln w="12700">
-            <a:solidFill>
-              <a:srgbClr val="f5c542"/>
-            </a:solidFill>
-          </a:ln>
-        </p:spPr>
-        <p:txBody>
-          <a:bodyPr/>
-          <a:lstStyle/>
-          <a:p/>
-        </p:txBody>
-      </p:sp>
-      <p:sp>
-        <p:nvSpPr>
-          <p:cNvPr id="235" name="t"/>
-          <p:cNvSpPr txBox="1"/>
-          <p:nvPr/>
-        </p:nvSpPr>
-        <p:spPr>
-          <a:xfrm>
-            <a:off x="9850000" y="520000"/>
-            <a:ext cx="1850000" cy="250000"/>
-          </a:xfrm>
-          <a:prstGeom prst="rect">
-            <a:avLst/>
-          </a:prstGeom>
-          <a:noFill/>
-        </p:spPr>
-        <p:txBody>
-          <a:bodyPr wrap="square" anchor="t">
-            <a:normAutofit/>
-          </a:bodyPr>
-          <a:lstStyle/>
-          <a:p>
-            <a:pPr algn="ctr"/>
-            <a:r>
-              <a:rPr lang="th-TH" sz="800" b="1" i="0" dirty="0">
-                <a:solidFill>
-                  <a:srgbClr val="22d3ee"/>
-                </a:solidFill>
-                <a:latin typeface="Tahoma"/>
-                <a:cs typeface="Tahoma"/>
-              </a:rPr>
-              <a:t>เกณฑ์ที่เกี่ยวข้อง</a:t>
-            </a:r>
-          </a:p>
-        </p:txBody>
-      </p:sp>
-      <p:sp>
-        <p:nvSpPr>
-          <p:cNvPr id="236" name="t"/>
-          <p:cNvSpPr txBox="1"/>
-          <p:nvPr/>
-        </p:nvSpPr>
-        <p:spPr>
-          <a:xfrm>
-            <a:off x="9850000" y="740000"/>
-            <a:ext cx="1850000" cy="260000"/>
-          </a:xfrm>
-          <a:prstGeom prst="rect">
-            <a:avLst/>
-          </a:prstGeom>
-          <a:noFill/>
-        </p:spPr>
-        <p:txBody>
-          <a:bodyPr wrap="square" anchor="t">
-            <a:normAutofit/>
-          </a:bodyPr>
-          <a:lstStyle/>
-          <a:p>
-            <a:pPr algn="ctr"/>
-            <a:r>
-              <a:rPr lang="th-TH" sz="1200" b="1" i="0" dirty="0">
-                <a:solidFill>
-                  <a:srgbClr val="f5c542"/>
-                </a:solidFill>
-                <a:latin typeface="Tahoma"/>
-                <a:cs typeface="Tahoma"/>
-              </a:rPr>
-              <a:t>20 คะแนน</a:t>
-            </a:r>
-          </a:p>
-        </p:txBody>
-      </p:sp>
-      <p:sp>
-        <p:nvSpPr>
-          <p:cNvPr id="237" name="s"/>
+          <p:cNvPr id="228" name="s"/>
           <p:cNvSpPr/>
           <p:nvPr/>
         </p:nvSpPr>
@@ -10142,7 +9839,7 @@
       </p:sp>
       <p:sp>
         <p:nvSpPr>
-          <p:cNvPr id="238" name="s"/>
+          <p:cNvPr id="229" name="s"/>
           <p:cNvSpPr/>
           <p:nvPr/>
         </p:nvSpPr>
@@ -10171,7 +9868,7 @@
       </p:sp>
       <p:sp>
         <p:nvSpPr>
-          <p:cNvPr id="239" name="s"/>
+          <p:cNvPr id="230" name="s"/>
           <p:cNvSpPr/>
           <p:nvPr/>
         </p:nvSpPr>
@@ -10198,7 +9895,7 @@
       </p:sp>
       <p:sp>
         <p:nvSpPr>
-          <p:cNvPr id="240" name="s"/>
+          <p:cNvPr id="231" name="s"/>
           <p:cNvSpPr/>
           <p:nvPr/>
         </p:nvSpPr>
@@ -10225,7 +9922,7 @@
       </p:sp>
       <p:sp>
         <p:nvSpPr>
-          <p:cNvPr id="241" name="s"/>
+          <p:cNvPr id="232" name="s"/>
           <p:cNvSpPr/>
           <p:nvPr/>
         </p:nvSpPr>
@@ -10252,7 +9949,7 @@
       </p:sp>
       <p:sp>
         <p:nvSpPr>
-          <p:cNvPr id="242" name="t"/>
+          <p:cNvPr id="233" name="t"/>
           <p:cNvSpPr txBox="1"/>
           <p:nvPr/>
         </p:nvSpPr>
@@ -10288,7 +9985,7 @@
       </p:sp>
       <p:sp>
         <p:nvSpPr>
-          <p:cNvPr id="243" name="s"/>
+          <p:cNvPr id="234" name="s"/>
           <p:cNvSpPr/>
           <p:nvPr/>
         </p:nvSpPr>
@@ -10322,7 +10019,7 @@
       </p:sp>
       <p:cxnSp>
         <p:nvCxnSpPr>
-          <p:cNvPr id="244" name="l"/>
+          <p:cNvPr id="235" name="l"/>
           <p:cNvCxnSpPr/>
           <p:nvPr/>
         </p:nvCxnSpPr>
@@ -10348,7 +10045,7 @@
       </p:cxnSp>
       <p:sp>
         <p:nvSpPr>
-          <p:cNvPr id="245" name="s"/>
+          <p:cNvPr id="236" name="s"/>
           <p:cNvSpPr/>
           <p:nvPr/>
         </p:nvSpPr>
@@ -10382,7 +10079,7 @@
       </p:sp>
       <p:cxnSp>
         <p:nvCxnSpPr>
-          <p:cNvPr id="246" name="l"/>
+          <p:cNvPr id="237" name="l"/>
           <p:cNvCxnSpPr/>
           <p:nvPr/>
         </p:nvCxnSpPr>
@@ -10408,7 +10105,7 @@
       </p:cxnSp>
       <p:sp>
         <p:nvSpPr>
-          <p:cNvPr id="247" name="s"/>
+          <p:cNvPr id="238" name="s"/>
           <p:cNvSpPr/>
           <p:nvPr/>
         </p:nvSpPr>
@@ -10442,7 +10139,7 @@
       </p:sp>
       <p:cxnSp>
         <p:nvCxnSpPr>
-          <p:cNvPr id="248" name="l"/>
+          <p:cNvPr id="239" name="l"/>
           <p:cNvCxnSpPr/>
           <p:nvPr/>
         </p:nvCxnSpPr>
@@ -10468,7 +10165,7 @@
       </p:cxnSp>
       <p:sp>
         <p:nvSpPr>
-          <p:cNvPr id="249" name="s"/>
+          <p:cNvPr id="240" name="s"/>
           <p:cNvSpPr/>
           <p:nvPr/>
         </p:nvSpPr>
@@ -10502,7 +10199,7 @@
       </p:sp>
       <p:cxnSp>
         <p:nvCxnSpPr>
-          <p:cNvPr id="250" name="l"/>
+          <p:cNvPr id="241" name="l"/>
           <p:cNvCxnSpPr/>
           <p:nvPr/>
         </p:nvCxnSpPr>
@@ -10528,7 +10225,7 @@
       </p:cxnSp>
       <p:sp>
         <p:nvSpPr>
-          <p:cNvPr id="251" name="s"/>
+          <p:cNvPr id="242" name="s"/>
           <p:cNvSpPr/>
           <p:nvPr/>
         </p:nvSpPr>
@@ -10562,7 +10259,7 @@
       </p:sp>
       <p:cxnSp>
         <p:nvCxnSpPr>
-          <p:cNvPr id="252" name="l"/>
+          <p:cNvPr id="243" name="l"/>
           <p:cNvCxnSpPr/>
           <p:nvPr/>
         </p:nvCxnSpPr>
@@ -10588,7 +10285,7 @@
       </p:cxnSp>
       <p:sp>
         <p:nvSpPr>
-          <p:cNvPr id="253" name="s"/>
+          <p:cNvPr id="244" name="s"/>
           <p:cNvSpPr/>
           <p:nvPr/>
         </p:nvSpPr>
@@ -10622,7 +10319,7 @@
       </p:sp>
       <p:sp>
         <p:nvSpPr>
-          <p:cNvPr id="254" name="t"/>
+          <p:cNvPr id="245" name="t"/>
           <p:cNvSpPr txBox="1"/>
           <p:nvPr/>
         </p:nvSpPr>
@@ -10658,7 +10355,7 @@
       </p:sp>
       <p:sp>
         <p:nvSpPr>
-          <p:cNvPr id="255" name="t"/>
+          <p:cNvPr id="246" name="t"/>
           <p:cNvSpPr txBox="1"/>
           <p:nvPr/>
         </p:nvSpPr>
@@ -10694,7 +10391,7 @@
       </p:sp>
       <p:sp>
         <p:nvSpPr>
-          <p:cNvPr id="256" name="t"/>
+          <p:cNvPr id="247" name="t"/>
           <p:cNvSpPr txBox="1"/>
           <p:nvPr/>
         </p:nvSpPr>
@@ -10740,7 +10437,7 @@
       </p:sp>
       <p:sp>
         <p:nvSpPr>
-          <p:cNvPr id="257" name="t"/>
+          <p:cNvPr id="248" name="t"/>
           <p:cNvSpPr txBox="1"/>
           <p:nvPr/>
         </p:nvSpPr>
@@ -10786,7 +10483,7 @@
       </p:sp>
       <p:sp>
         <p:nvSpPr>
-          <p:cNvPr id="258" name="t"/>
+          <p:cNvPr id="249" name="t"/>
           <p:cNvSpPr txBox="1"/>
           <p:nvPr/>
         </p:nvSpPr>
@@ -10832,7 +10529,7 @@
       </p:sp>
       <p:sp>
         <p:nvSpPr>
-          <p:cNvPr id="259" name="t"/>
+          <p:cNvPr id="250" name="t"/>
           <p:cNvSpPr txBox="1"/>
           <p:nvPr/>
         </p:nvSpPr>
@@ -10878,7 +10575,7 @@
       </p:sp>
       <p:sp>
         <p:nvSpPr>
-          <p:cNvPr id="260" name="t"/>
+          <p:cNvPr id="251" name="t"/>
           <p:cNvSpPr txBox="1"/>
           <p:nvPr/>
         </p:nvSpPr>
@@ -10924,7 +10621,7 @@
       </p:sp>
       <p:sp>
         <p:nvSpPr>
-          <p:cNvPr id="261" name="t"/>
+          <p:cNvPr id="252" name="t"/>
           <p:cNvSpPr txBox="1"/>
           <p:nvPr/>
         </p:nvSpPr>
@@ -10970,7 +10667,7 @@
       </p:sp>
       <p:sp>
         <p:nvSpPr>
-          <p:cNvPr id="262" name="s"/>
+          <p:cNvPr id="253" name="s"/>
           <p:cNvSpPr/>
           <p:nvPr/>
         </p:nvSpPr>
@@ -10999,7 +10696,7 @@
       </p:sp>
       <p:sp>
         <p:nvSpPr>
-          <p:cNvPr id="263" name="t"/>
+          <p:cNvPr id="254" name="t"/>
           <p:cNvSpPr txBox="1"/>
           <p:nvPr/>
         </p:nvSpPr>
@@ -11078,7 +10775,7 @@
       </p:grpSpPr>
       <p:sp>
         <p:nvSpPr>
-          <p:cNvPr id="264" name="s"/>
+          <p:cNvPr id="255" name="s"/>
           <p:cNvSpPr/>
           <p:nvPr/>
         </p:nvSpPr>
@@ -11107,7 +10804,7 @@
       </p:sp>
       <p:sp>
         <p:nvSpPr>
-          <p:cNvPr id="265" name="t"/>
+          <p:cNvPr id="256" name="t"/>
           <p:cNvSpPr txBox="1"/>
           <p:nvPr/>
         </p:nvSpPr>
@@ -11143,7 +10840,7 @@
       </p:sp>
       <p:sp>
         <p:nvSpPr>
-          <p:cNvPr id="266" name="t"/>
+          <p:cNvPr id="257" name="t"/>
           <p:cNvSpPr txBox="1"/>
           <p:nvPr/>
         </p:nvSpPr>
@@ -11179,7 +10876,7 @@
       </p:sp>
       <p:sp>
         <p:nvSpPr>
-          <p:cNvPr id="267" name="t"/>
+          <p:cNvPr id="258" name="t"/>
           <p:cNvSpPr txBox="1"/>
           <p:nvPr/>
         </p:nvSpPr>
@@ -11215,108 +10912,7 @@
       </p:sp>
       <p:sp>
         <p:nvSpPr>
-          <p:cNvPr id="268" name="s"/>
-          <p:cNvSpPr/>
-          <p:nvPr/>
-        </p:nvSpPr>
-        <p:spPr>
-          <a:xfrm>
-            <a:off x="9850000" y="470000"/>
-            <a:ext cx="1850000" cy="560000"/>
-          </a:xfrm>
-          <a:prstGeom prst="roundRect">
-            <a:avLst>
-              <a:gd name="adj" fmla="val 16000"/>
-            </a:avLst>
-          </a:prstGeom>
-          <a:noFill/>
-          <a:ln w="12700">
-            <a:solidFill>
-              <a:srgbClr val="f5c542"/>
-            </a:solidFill>
-          </a:ln>
-        </p:spPr>
-        <p:txBody>
-          <a:bodyPr/>
-          <a:lstStyle/>
-          <a:p/>
-        </p:txBody>
-      </p:sp>
-      <p:sp>
-        <p:nvSpPr>
-          <p:cNvPr id="269" name="t"/>
-          <p:cNvSpPr txBox="1"/>
-          <p:nvPr/>
-        </p:nvSpPr>
-        <p:spPr>
-          <a:xfrm>
-            <a:off x="9850000" y="520000"/>
-            <a:ext cx="1850000" cy="250000"/>
-          </a:xfrm>
-          <a:prstGeom prst="rect">
-            <a:avLst/>
-          </a:prstGeom>
-          <a:noFill/>
-        </p:spPr>
-        <p:txBody>
-          <a:bodyPr wrap="square" anchor="t">
-            <a:normAutofit/>
-          </a:bodyPr>
-          <a:lstStyle/>
-          <a:p>
-            <a:pPr algn="ctr"/>
-            <a:r>
-              <a:rPr lang="th-TH" sz="800" b="1" i="0" dirty="0">
-                <a:solidFill>
-                  <a:srgbClr val="22d3ee"/>
-                </a:solidFill>
-                <a:latin typeface="Tahoma"/>
-                <a:cs typeface="Tahoma"/>
-              </a:rPr>
-              <a:t>เกณฑ์ที่เกี่ยวข้อง</a:t>
-            </a:r>
-          </a:p>
-        </p:txBody>
-      </p:sp>
-      <p:sp>
-        <p:nvSpPr>
-          <p:cNvPr id="270" name="t"/>
-          <p:cNvSpPr txBox="1"/>
-          <p:nvPr/>
-        </p:nvSpPr>
-        <p:spPr>
-          <a:xfrm>
-            <a:off x="9850000" y="740000"/>
-            <a:ext cx="1850000" cy="260000"/>
-          </a:xfrm>
-          <a:prstGeom prst="rect">
-            <a:avLst/>
-          </a:prstGeom>
-          <a:noFill/>
-        </p:spPr>
-        <p:txBody>
-          <a:bodyPr wrap="square" anchor="t">
-            <a:normAutofit/>
-          </a:bodyPr>
-          <a:lstStyle/>
-          <a:p>
-            <a:pPr algn="ctr"/>
-            <a:r>
-              <a:rPr lang="th-TH" sz="1200" b="1" i="0" dirty="0">
-                <a:solidFill>
-                  <a:srgbClr val="f5c542"/>
-                </a:solidFill>
-                <a:latin typeface="Tahoma"/>
-                <a:cs typeface="Tahoma"/>
-              </a:rPr>
-              <a:t>30 คะแนน</a:t>
-            </a:r>
-          </a:p>
-        </p:txBody>
-      </p:sp>
-      <p:sp>
-        <p:nvSpPr>
-          <p:cNvPr id="271" name="s"/>
+          <p:cNvPr id="259" name="s"/>
           <p:cNvSpPr/>
           <p:nvPr/>
         </p:nvSpPr>
@@ -11347,7 +10943,7 @@
       </p:sp>
       <p:sp>
         <p:nvSpPr>
-          <p:cNvPr id="272" name="s"/>
+          <p:cNvPr id="260" name="s"/>
           <p:cNvSpPr/>
           <p:nvPr/>
         </p:nvSpPr>
@@ -11383,7 +10979,7 @@
       </p:sp>
       <p:sp>
         <p:nvSpPr>
-          <p:cNvPr id="273" name="t"/>
+          <p:cNvPr id="261" name="t"/>
           <p:cNvSpPr txBox="1"/>
           <p:nvPr/>
         </p:nvSpPr>
@@ -11419,7 +11015,7 @@
       </p:sp>
       <p:sp>
         <p:nvSpPr>
-          <p:cNvPr id="274" name="t"/>
+          <p:cNvPr id="262" name="t"/>
           <p:cNvSpPr txBox="1"/>
           <p:nvPr/>
         </p:nvSpPr>
@@ -11455,7 +11051,7 @@
       </p:sp>
       <p:sp>
         <p:nvSpPr>
-          <p:cNvPr id="275" name="t"/>
+          <p:cNvPr id="263" name="t"/>
           <p:cNvSpPr txBox="1"/>
           <p:nvPr/>
         </p:nvSpPr>
@@ -11491,7 +11087,7 @@
       </p:sp>
       <p:sp>
         <p:nvSpPr>
-          <p:cNvPr id="276" name="s"/>
+          <p:cNvPr id="264" name="s"/>
           <p:cNvSpPr/>
           <p:nvPr/>
         </p:nvSpPr>
@@ -11522,7 +11118,7 @@
       </p:sp>
       <p:sp>
         <p:nvSpPr>
-          <p:cNvPr id="277" name="s"/>
+          <p:cNvPr id="265" name="s"/>
           <p:cNvSpPr/>
           <p:nvPr/>
         </p:nvSpPr>
@@ -11558,7 +11154,7 @@
       </p:sp>
       <p:sp>
         <p:nvSpPr>
-          <p:cNvPr id="278" name="t"/>
+          <p:cNvPr id="266" name="t"/>
           <p:cNvSpPr txBox="1"/>
           <p:nvPr/>
         </p:nvSpPr>
@@ -11594,7 +11190,7 @@
       </p:sp>
       <p:sp>
         <p:nvSpPr>
-          <p:cNvPr id="279" name="t"/>
+          <p:cNvPr id="267" name="t"/>
           <p:cNvSpPr txBox="1"/>
           <p:nvPr/>
         </p:nvSpPr>
@@ -11630,7 +11226,7 @@
       </p:sp>
       <p:sp>
         <p:nvSpPr>
-          <p:cNvPr id="280" name="t"/>
+          <p:cNvPr id="268" name="t"/>
           <p:cNvSpPr txBox="1"/>
           <p:nvPr/>
         </p:nvSpPr>
@@ -11666,7 +11262,7 @@
       </p:sp>
       <p:sp>
         <p:nvSpPr>
-          <p:cNvPr id="281" name="s"/>
+          <p:cNvPr id="269" name="s"/>
           <p:cNvSpPr/>
           <p:nvPr/>
         </p:nvSpPr>
@@ -11697,7 +11293,7 @@
       </p:sp>
       <p:sp>
         <p:nvSpPr>
-          <p:cNvPr id="282" name="s"/>
+          <p:cNvPr id="270" name="s"/>
           <p:cNvSpPr/>
           <p:nvPr/>
         </p:nvSpPr>
@@ -11733,7 +11329,7 @@
       </p:sp>
       <p:sp>
         <p:nvSpPr>
-          <p:cNvPr id="283" name="t"/>
+          <p:cNvPr id="271" name="t"/>
           <p:cNvSpPr txBox="1"/>
           <p:nvPr/>
         </p:nvSpPr>
@@ -11769,7 +11365,7 @@
       </p:sp>
       <p:sp>
         <p:nvSpPr>
-          <p:cNvPr id="284" name="t"/>
+          <p:cNvPr id="272" name="t"/>
           <p:cNvSpPr txBox="1"/>
           <p:nvPr/>
         </p:nvSpPr>
@@ -11805,7 +11401,7 @@
       </p:sp>
       <p:sp>
         <p:nvSpPr>
-          <p:cNvPr id="285" name="t"/>
+          <p:cNvPr id="273" name="t"/>
           <p:cNvSpPr txBox="1"/>
           <p:nvPr/>
         </p:nvSpPr>
@@ -11841,7 +11437,7 @@
       </p:sp>
       <p:sp>
         <p:nvSpPr>
-          <p:cNvPr id="286" name="s"/>
+          <p:cNvPr id="274" name="s"/>
           <p:cNvSpPr/>
           <p:nvPr/>
         </p:nvSpPr>
@@ -11872,7 +11468,7 @@
       </p:sp>
       <p:sp>
         <p:nvSpPr>
-          <p:cNvPr id="287" name="s"/>
+          <p:cNvPr id="275" name="s"/>
           <p:cNvSpPr/>
           <p:nvPr/>
         </p:nvSpPr>
@@ -11908,7 +11504,7 @@
       </p:sp>
       <p:sp>
         <p:nvSpPr>
-          <p:cNvPr id="288" name="t"/>
+          <p:cNvPr id="276" name="t"/>
           <p:cNvSpPr txBox="1"/>
           <p:nvPr/>
         </p:nvSpPr>
@@ -11944,7 +11540,7 @@
       </p:sp>
       <p:sp>
         <p:nvSpPr>
-          <p:cNvPr id="289" name="t"/>
+          <p:cNvPr id="277" name="t"/>
           <p:cNvSpPr txBox="1"/>
           <p:nvPr/>
         </p:nvSpPr>
@@ -11980,7 +11576,7 @@
       </p:sp>
       <p:sp>
         <p:nvSpPr>
-          <p:cNvPr id="290" name="t"/>
+          <p:cNvPr id="278" name="t"/>
           <p:cNvSpPr txBox="1"/>
           <p:nvPr/>
         </p:nvSpPr>
@@ -12016,7 +11612,7 @@
       </p:sp>
       <p:sp>
         <p:nvSpPr>
-          <p:cNvPr id="291" name="s"/>
+          <p:cNvPr id="279" name="s"/>
           <p:cNvSpPr/>
           <p:nvPr/>
         </p:nvSpPr>
@@ -12045,7 +11641,7 @@
       </p:sp>
       <p:sp>
         <p:nvSpPr>
-          <p:cNvPr id="292" name="t"/>
+          <p:cNvPr id="280" name="t"/>
           <p:cNvSpPr txBox="1"/>
           <p:nvPr/>
         </p:nvSpPr>
@@ -12081,7 +11677,7 @@
       </p:sp>
       <p:sp>
         <p:nvSpPr>
-          <p:cNvPr id="293" name="t"/>
+          <p:cNvPr id="281" name="t"/>
           <p:cNvSpPr txBox="1"/>
           <p:nvPr/>
         </p:nvSpPr>

</xml_diff>